<commit_message>
Update presentation: remove guide lines
</commit_message>
<xml_diff>
--- a/report/ALY6130_Group4_Presentation.pptx
+++ b/report/ALY6130_Group4_Presentation.pptx
@@ -2392,78 +2392,6 @@
           </a:p>
         </p:txBody>
       </p:sp>
-      <p:cxnSp>
-        <p:nvCxnSpPr>
-          <p:cNvPr id="14" name="Straight Connector 13">
-            <a:extLst>
-              <a:ext uri="{FF2B5EF4-FFF2-40B4-BE49-F238E27FC236}">
-                <a16:creationId xmlns:a16="http://schemas.microsoft.com/office/drawing/2014/main" id="{2A46ACD3-78FC-153F-0C9A-2D446FCCD262}"/>
-              </a:ext>
-            </a:extLst>
-          </p:cNvPr>
-          <p:cNvCxnSpPr/>
-          <p:nvPr/>
-        </p:nvCxnSpPr>
-        <p:spPr>
-          <a:xfrm>
-            <a:off x="16935" y="729823"/>
-            <a:ext cx="9144000" cy="0"/>
-          </a:xfrm>
-          <a:prstGeom prst="line">
-            <a:avLst/>
-          </a:prstGeom>
-        </p:spPr>
-        <p:style>
-          <a:lnRef idx="1">
-            <a:schemeClr val="accent1"/>
-          </a:lnRef>
-          <a:fillRef idx="0">
-            <a:schemeClr val="accent1"/>
-          </a:fillRef>
-          <a:effectRef idx="0">
-            <a:schemeClr val="accent1"/>
-          </a:effectRef>
-          <a:fontRef idx="minor">
-            <a:schemeClr val="tx1"/>
-          </a:fontRef>
-        </p:style>
-      </p:cxnSp>
-      <p:cxnSp>
-        <p:nvCxnSpPr>
-          <p:cNvPr id="15" name="Straight Connector 14">
-            <a:extLst>
-              <a:ext uri="{FF2B5EF4-FFF2-40B4-BE49-F238E27FC236}">
-                <a16:creationId xmlns:a16="http://schemas.microsoft.com/office/drawing/2014/main" id="{7DEB8BCE-2EA1-49D2-D156-2FE140CBE5D2}"/>
-              </a:ext>
-            </a:extLst>
-          </p:cNvPr>
-          <p:cNvCxnSpPr/>
-          <p:nvPr/>
-        </p:nvCxnSpPr>
-        <p:spPr>
-          <a:xfrm>
-            <a:off x="270933" y="0"/>
-            <a:ext cx="0" cy="5143500"/>
-          </a:xfrm>
-          <a:prstGeom prst="line">
-            <a:avLst/>
-          </a:prstGeom>
-        </p:spPr>
-        <p:style>
-          <a:lnRef idx="1">
-            <a:schemeClr val="accent1"/>
-          </a:lnRef>
-          <a:fillRef idx="0">
-            <a:schemeClr val="accent1"/>
-          </a:fillRef>
-          <a:effectRef idx="0">
-            <a:schemeClr val="accent1"/>
-          </a:effectRef>
-          <a:fontRef idx="minor">
-            <a:schemeClr val="tx1"/>
-          </a:fontRef>
-        </p:style>
-      </p:cxnSp>
     </p:spTree>
   </p:cSld>
   <p:clrMapOvr>
@@ -3163,78 +3091,6 @@
           </a:p>
         </p:txBody>
       </p:sp>
-      <p:cxnSp>
-        <p:nvCxnSpPr>
-          <p:cNvPr id="19" name="Straight Connector 18">
-            <a:extLst>
-              <a:ext uri="{FF2B5EF4-FFF2-40B4-BE49-F238E27FC236}">
-                <a16:creationId xmlns:a16="http://schemas.microsoft.com/office/drawing/2014/main" id="{887A0B4F-BEE4-9945-106B-B6FF1141EED4}"/>
-              </a:ext>
-            </a:extLst>
-          </p:cNvPr>
-          <p:cNvCxnSpPr/>
-          <p:nvPr/>
-        </p:nvCxnSpPr>
-        <p:spPr>
-          <a:xfrm>
-            <a:off x="16935" y="729823"/>
-            <a:ext cx="9144000" cy="0"/>
-          </a:xfrm>
-          <a:prstGeom prst="line">
-            <a:avLst/>
-          </a:prstGeom>
-        </p:spPr>
-        <p:style>
-          <a:lnRef idx="1">
-            <a:schemeClr val="accent1"/>
-          </a:lnRef>
-          <a:fillRef idx="0">
-            <a:schemeClr val="accent1"/>
-          </a:fillRef>
-          <a:effectRef idx="0">
-            <a:schemeClr val="accent1"/>
-          </a:effectRef>
-          <a:fontRef idx="minor">
-            <a:schemeClr val="tx1"/>
-          </a:fontRef>
-        </p:style>
-      </p:cxnSp>
-      <p:cxnSp>
-        <p:nvCxnSpPr>
-          <p:cNvPr id="20" name="Straight Connector 19">
-            <a:extLst>
-              <a:ext uri="{FF2B5EF4-FFF2-40B4-BE49-F238E27FC236}">
-                <a16:creationId xmlns:a16="http://schemas.microsoft.com/office/drawing/2014/main" id="{28DF1C05-A513-7DD8-8023-2AC577B2AABD}"/>
-              </a:ext>
-            </a:extLst>
-          </p:cNvPr>
-          <p:cNvCxnSpPr/>
-          <p:nvPr/>
-        </p:nvCxnSpPr>
-        <p:spPr>
-          <a:xfrm>
-            <a:off x="270933" y="0"/>
-            <a:ext cx="0" cy="5143500"/>
-          </a:xfrm>
-          <a:prstGeom prst="line">
-            <a:avLst/>
-          </a:prstGeom>
-        </p:spPr>
-        <p:style>
-          <a:lnRef idx="1">
-            <a:schemeClr val="accent1"/>
-          </a:lnRef>
-          <a:fillRef idx="0">
-            <a:schemeClr val="accent1"/>
-          </a:fillRef>
-          <a:effectRef idx="0">
-            <a:schemeClr val="accent1"/>
-          </a:effectRef>
-          <a:fontRef idx="minor">
-            <a:schemeClr val="tx1"/>
-          </a:fontRef>
-        </p:style>
-      </p:cxnSp>
     </p:spTree>
   </p:cSld>
   <p:clrMapOvr>
@@ -3456,78 +3312,6 @@
           </a:p>
         </p:txBody>
       </p:sp>
-      <p:cxnSp>
-        <p:nvCxnSpPr>
-          <p:cNvPr id="8" name="Straight Connector 7">
-            <a:extLst>
-              <a:ext uri="{FF2B5EF4-FFF2-40B4-BE49-F238E27FC236}">
-                <a16:creationId xmlns:a16="http://schemas.microsoft.com/office/drawing/2014/main" id="{5D59A6BE-E82D-EC90-686D-0C325F9AE56E}"/>
-              </a:ext>
-            </a:extLst>
-          </p:cNvPr>
-          <p:cNvCxnSpPr/>
-          <p:nvPr/>
-        </p:nvCxnSpPr>
-        <p:spPr>
-          <a:xfrm>
-            <a:off x="16935" y="729823"/>
-            <a:ext cx="9144000" cy="0"/>
-          </a:xfrm>
-          <a:prstGeom prst="line">
-            <a:avLst/>
-          </a:prstGeom>
-        </p:spPr>
-        <p:style>
-          <a:lnRef idx="1">
-            <a:schemeClr val="accent1"/>
-          </a:lnRef>
-          <a:fillRef idx="0">
-            <a:schemeClr val="accent1"/>
-          </a:fillRef>
-          <a:effectRef idx="0">
-            <a:schemeClr val="accent1"/>
-          </a:effectRef>
-          <a:fontRef idx="minor">
-            <a:schemeClr val="tx1"/>
-          </a:fontRef>
-        </p:style>
-      </p:cxnSp>
-      <p:cxnSp>
-        <p:nvCxnSpPr>
-          <p:cNvPr id="9" name="Straight Connector 8">
-            <a:extLst>
-              <a:ext uri="{FF2B5EF4-FFF2-40B4-BE49-F238E27FC236}">
-                <a16:creationId xmlns:a16="http://schemas.microsoft.com/office/drawing/2014/main" id="{420BEDE3-7D71-3392-CB52-297B075C101C}"/>
-              </a:ext>
-            </a:extLst>
-          </p:cNvPr>
-          <p:cNvCxnSpPr/>
-          <p:nvPr/>
-        </p:nvCxnSpPr>
-        <p:spPr>
-          <a:xfrm>
-            <a:off x="270933" y="0"/>
-            <a:ext cx="0" cy="5143500"/>
-          </a:xfrm>
-          <a:prstGeom prst="line">
-            <a:avLst/>
-          </a:prstGeom>
-        </p:spPr>
-        <p:style>
-          <a:lnRef idx="1">
-            <a:schemeClr val="accent1"/>
-          </a:lnRef>
-          <a:fillRef idx="0">
-            <a:schemeClr val="accent1"/>
-          </a:fillRef>
-          <a:effectRef idx="0">
-            <a:schemeClr val="accent1"/>
-          </a:effectRef>
-          <a:fontRef idx="minor">
-            <a:schemeClr val="tx1"/>
-          </a:fontRef>
-        </p:style>
-      </p:cxnSp>
     </p:spTree>
   </p:cSld>
   <p:clrMapOvr>
@@ -4560,78 +4344,6 @@
           </a:p>
         </p:txBody>
       </p:sp>
-      <p:cxnSp>
-        <p:nvCxnSpPr>
-          <p:cNvPr id="28" name="Straight Connector 27">
-            <a:extLst>
-              <a:ext uri="{FF2B5EF4-FFF2-40B4-BE49-F238E27FC236}">
-                <a16:creationId xmlns:a16="http://schemas.microsoft.com/office/drawing/2014/main" id="{C4F84FB4-5811-6B89-D0C7-A1E437A58357}"/>
-              </a:ext>
-            </a:extLst>
-          </p:cNvPr>
-          <p:cNvCxnSpPr/>
-          <p:nvPr/>
-        </p:nvCxnSpPr>
-        <p:spPr>
-          <a:xfrm>
-            <a:off x="16935" y="729823"/>
-            <a:ext cx="9144000" cy="0"/>
-          </a:xfrm>
-          <a:prstGeom prst="line">
-            <a:avLst/>
-          </a:prstGeom>
-        </p:spPr>
-        <p:style>
-          <a:lnRef idx="1">
-            <a:schemeClr val="accent1"/>
-          </a:lnRef>
-          <a:fillRef idx="0">
-            <a:schemeClr val="accent1"/>
-          </a:fillRef>
-          <a:effectRef idx="0">
-            <a:schemeClr val="accent1"/>
-          </a:effectRef>
-          <a:fontRef idx="minor">
-            <a:schemeClr val="tx1"/>
-          </a:fontRef>
-        </p:style>
-      </p:cxnSp>
-      <p:cxnSp>
-        <p:nvCxnSpPr>
-          <p:cNvPr id="30" name="Straight Connector 29">
-            <a:extLst>
-              <a:ext uri="{FF2B5EF4-FFF2-40B4-BE49-F238E27FC236}">
-                <a16:creationId xmlns:a16="http://schemas.microsoft.com/office/drawing/2014/main" id="{A18AAAA6-27F8-F69F-B2B4-BA420EFF59C0}"/>
-              </a:ext>
-            </a:extLst>
-          </p:cNvPr>
-          <p:cNvCxnSpPr/>
-          <p:nvPr/>
-        </p:nvCxnSpPr>
-        <p:spPr>
-          <a:xfrm>
-            <a:off x="270933" y="0"/>
-            <a:ext cx="0" cy="5143500"/>
-          </a:xfrm>
-          <a:prstGeom prst="line">
-            <a:avLst/>
-          </a:prstGeom>
-        </p:spPr>
-        <p:style>
-          <a:lnRef idx="1">
-            <a:schemeClr val="accent1"/>
-          </a:lnRef>
-          <a:fillRef idx="0">
-            <a:schemeClr val="accent1"/>
-          </a:fillRef>
-          <a:effectRef idx="0">
-            <a:schemeClr val="accent1"/>
-          </a:effectRef>
-          <a:fontRef idx="minor">
-            <a:schemeClr val="tx1"/>
-          </a:fontRef>
-        </p:style>
-      </p:cxnSp>
       <p:sp>
         <p:nvSpPr>
           <p:cNvPr id="31" name="TextBox 30">
@@ -5556,78 +5268,6 @@
           </a:p>
         </p:txBody>
       </p:sp>
-      <p:cxnSp>
-        <p:nvCxnSpPr>
-          <p:cNvPr id="24" name="Straight Connector 23">
-            <a:extLst>
-              <a:ext uri="{FF2B5EF4-FFF2-40B4-BE49-F238E27FC236}">
-                <a16:creationId xmlns:a16="http://schemas.microsoft.com/office/drawing/2014/main" id="{3A7EA6E3-609F-CCD7-F584-23CD246B9648}"/>
-              </a:ext>
-            </a:extLst>
-          </p:cNvPr>
-          <p:cNvCxnSpPr/>
-          <p:nvPr/>
-        </p:nvCxnSpPr>
-        <p:spPr>
-          <a:xfrm>
-            <a:off x="16935" y="729823"/>
-            <a:ext cx="9144000" cy="0"/>
-          </a:xfrm>
-          <a:prstGeom prst="line">
-            <a:avLst/>
-          </a:prstGeom>
-        </p:spPr>
-        <p:style>
-          <a:lnRef idx="1">
-            <a:schemeClr val="accent1"/>
-          </a:lnRef>
-          <a:fillRef idx="0">
-            <a:schemeClr val="accent1"/>
-          </a:fillRef>
-          <a:effectRef idx="0">
-            <a:schemeClr val="accent1"/>
-          </a:effectRef>
-          <a:fontRef idx="minor">
-            <a:schemeClr val="tx1"/>
-          </a:fontRef>
-        </p:style>
-      </p:cxnSp>
-      <p:cxnSp>
-        <p:nvCxnSpPr>
-          <p:cNvPr id="25" name="Straight Connector 24">
-            <a:extLst>
-              <a:ext uri="{FF2B5EF4-FFF2-40B4-BE49-F238E27FC236}">
-                <a16:creationId xmlns:a16="http://schemas.microsoft.com/office/drawing/2014/main" id="{0AF9FCA1-7778-1B6B-1E5B-B1FAE5355755}"/>
-              </a:ext>
-            </a:extLst>
-          </p:cNvPr>
-          <p:cNvCxnSpPr/>
-          <p:nvPr/>
-        </p:nvCxnSpPr>
-        <p:spPr>
-          <a:xfrm>
-            <a:off x="270933" y="0"/>
-            <a:ext cx="0" cy="5143500"/>
-          </a:xfrm>
-          <a:prstGeom prst="line">
-            <a:avLst/>
-          </a:prstGeom>
-        </p:spPr>
-        <p:style>
-          <a:lnRef idx="1">
-            <a:schemeClr val="accent1"/>
-          </a:lnRef>
-          <a:fillRef idx="0">
-            <a:schemeClr val="accent1"/>
-          </a:fillRef>
-          <a:effectRef idx="0">
-            <a:schemeClr val="accent1"/>
-          </a:effectRef>
-          <a:fontRef idx="minor">
-            <a:schemeClr val="tx1"/>
-          </a:fontRef>
-        </p:style>
-      </p:cxnSp>
     </p:spTree>
   </p:cSld>
   <p:clrMapOvr>
@@ -6581,78 +6221,6 @@
           </a:p>
         </p:txBody>
       </p:sp>
-      <p:cxnSp>
-        <p:nvCxnSpPr>
-          <p:cNvPr id="27" name="Straight Connector 26">
-            <a:extLst>
-              <a:ext uri="{FF2B5EF4-FFF2-40B4-BE49-F238E27FC236}">
-                <a16:creationId xmlns:a16="http://schemas.microsoft.com/office/drawing/2014/main" id="{D398EE44-C9AC-2E09-DD67-770964C2B96B}"/>
-              </a:ext>
-            </a:extLst>
-          </p:cNvPr>
-          <p:cNvCxnSpPr/>
-          <p:nvPr/>
-        </p:nvCxnSpPr>
-        <p:spPr>
-          <a:xfrm>
-            <a:off x="16935" y="729823"/>
-            <a:ext cx="9144000" cy="0"/>
-          </a:xfrm>
-          <a:prstGeom prst="line">
-            <a:avLst/>
-          </a:prstGeom>
-        </p:spPr>
-        <p:style>
-          <a:lnRef idx="1">
-            <a:schemeClr val="accent1"/>
-          </a:lnRef>
-          <a:fillRef idx="0">
-            <a:schemeClr val="accent1"/>
-          </a:fillRef>
-          <a:effectRef idx="0">
-            <a:schemeClr val="accent1"/>
-          </a:effectRef>
-          <a:fontRef idx="minor">
-            <a:schemeClr val="tx1"/>
-          </a:fontRef>
-        </p:style>
-      </p:cxnSp>
-      <p:cxnSp>
-        <p:nvCxnSpPr>
-          <p:cNvPr id="28" name="Straight Connector 27">
-            <a:extLst>
-              <a:ext uri="{FF2B5EF4-FFF2-40B4-BE49-F238E27FC236}">
-                <a16:creationId xmlns:a16="http://schemas.microsoft.com/office/drawing/2014/main" id="{CFFB155D-CF4B-13C4-3304-4299F4B3E701}"/>
-              </a:ext>
-            </a:extLst>
-          </p:cNvPr>
-          <p:cNvCxnSpPr/>
-          <p:nvPr/>
-        </p:nvCxnSpPr>
-        <p:spPr>
-          <a:xfrm>
-            <a:off x="270933" y="0"/>
-            <a:ext cx="0" cy="5143500"/>
-          </a:xfrm>
-          <a:prstGeom prst="line">
-            <a:avLst/>
-          </a:prstGeom>
-        </p:spPr>
-        <p:style>
-          <a:lnRef idx="1">
-            <a:schemeClr val="accent1"/>
-          </a:lnRef>
-          <a:fillRef idx="0">
-            <a:schemeClr val="accent1"/>
-          </a:fillRef>
-          <a:effectRef idx="0">
-            <a:schemeClr val="accent1"/>
-          </a:effectRef>
-          <a:fontRef idx="minor">
-            <a:schemeClr val="tx1"/>
-          </a:fontRef>
-        </p:style>
-      </p:cxnSp>
     </p:spTree>
   </p:cSld>
   <p:clrMapOvr>
@@ -8790,78 +8358,6 @@
           </a:p>
         </p:txBody>
       </p:sp>
-      <p:cxnSp>
-        <p:nvCxnSpPr>
-          <p:cNvPr id="14" name="Straight Connector 13">
-            <a:extLst>
-              <a:ext uri="{FF2B5EF4-FFF2-40B4-BE49-F238E27FC236}">
-                <a16:creationId xmlns:a16="http://schemas.microsoft.com/office/drawing/2014/main" id="{A64CC58B-5113-5499-1715-41C4D4D0EA2C}"/>
-              </a:ext>
-            </a:extLst>
-          </p:cNvPr>
-          <p:cNvCxnSpPr/>
-          <p:nvPr/>
-        </p:nvCxnSpPr>
-        <p:spPr>
-          <a:xfrm>
-            <a:off x="16935" y="729823"/>
-            <a:ext cx="9144000" cy="0"/>
-          </a:xfrm>
-          <a:prstGeom prst="line">
-            <a:avLst/>
-          </a:prstGeom>
-        </p:spPr>
-        <p:style>
-          <a:lnRef idx="1">
-            <a:schemeClr val="accent1"/>
-          </a:lnRef>
-          <a:fillRef idx="0">
-            <a:schemeClr val="accent1"/>
-          </a:fillRef>
-          <a:effectRef idx="0">
-            <a:schemeClr val="accent1"/>
-          </a:effectRef>
-          <a:fontRef idx="minor">
-            <a:schemeClr val="tx1"/>
-          </a:fontRef>
-        </p:style>
-      </p:cxnSp>
-      <p:cxnSp>
-        <p:nvCxnSpPr>
-          <p:cNvPr id="15" name="Straight Connector 14">
-            <a:extLst>
-              <a:ext uri="{FF2B5EF4-FFF2-40B4-BE49-F238E27FC236}">
-                <a16:creationId xmlns:a16="http://schemas.microsoft.com/office/drawing/2014/main" id="{368583D4-7C9D-37F8-2B7D-1A9523C4B23A}"/>
-              </a:ext>
-            </a:extLst>
-          </p:cNvPr>
-          <p:cNvCxnSpPr/>
-          <p:nvPr/>
-        </p:nvCxnSpPr>
-        <p:spPr>
-          <a:xfrm>
-            <a:off x="270933" y="0"/>
-            <a:ext cx="0" cy="5143500"/>
-          </a:xfrm>
-          <a:prstGeom prst="line">
-            <a:avLst/>
-          </a:prstGeom>
-        </p:spPr>
-        <p:style>
-          <a:lnRef idx="1">
-            <a:schemeClr val="accent1"/>
-          </a:lnRef>
-          <a:fillRef idx="0">
-            <a:schemeClr val="accent1"/>
-          </a:fillRef>
-          <a:effectRef idx="0">
-            <a:schemeClr val="accent1"/>
-          </a:effectRef>
-          <a:fontRef idx="minor">
-            <a:schemeClr val="tx1"/>
-          </a:fontRef>
-        </p:style>
-      </p:cxnSp>
     </p:spTree>
   </p:cSld>
   <p:clrMapOvr>
@@ -9956,78 +9452,6 @@
           </a:p>
         </p:txBody>
       </p:sp>
-      <p:cxnSp>
-        <p:nvCxnSpPr>
-          <p:cNvPr id="28" name="Straight Connector 27">
-            <a:extLst>
-              <a:ext uri="{FF2B5EF4-FFF2-40B4-BE49-F238E27FC236}">
-                <a16:creationId xmlns:a16="http://schemas.microsoft.com/office/drawing/2014/main" id="{E53D5029-0D26-3045-C873-B88C4922F17A}"/>
-              </a:ext>
-            </a:extLst>
-          </p:cNvPr>
-          <p:cNvCxnSpPr/>
-          <p:nvPr/>
-        </p:nvCxnSpPr>
-        <p:spPr>
-          <a:xfrm>
-            <a:off x="16935" y="729823"/>
-            <a:ext cx="9144000" cy="0"/>
-          </a:xfrm>
-          <a:prstGeom prst="line">
-            <a:avLst/>
-          </a:prstGeom>
-        </p:spPr>
-        <p:style>
-          <a:lnRef idx="1">
-            <a:schemeClr val="accent1"/>
-          </a:lnRef>
-          <a:fillRef idx="0">
-            <a:schemeClr val="accent1"/>
-          </a:fillRef>
-          <a:effectRef idx="0">
-            <a:schemeClr val="accent1"/>
-          </a:effectRef>
-          <a:fontRef idx="minor">
-            <a:schemeClr val="tx1"/>
-          </a:fontRef>
-        </p:style>
-      </p:cxnSp>
-      <p:cxnSp>
-        <p:nvCxnSpPr>
-          <p:cNvPr id="29" name="Straight Connector 28">
-            <a:extLst>
-              <a:ext uri="{FF2B5EF4-FFF2-40B4-BE49-F238E27FC236}">
-                <a16:creationId xmlns:a16="http://schemas.microsoft.com/office/drawing/2014/main" id="{EF519E77-4ED3-0F6E-8F25-6749347238E2}"/>
-              </a:ext>
-            </a:extLst>
-          </p:cNvPr>
-          <p:cNvCxnSpPr/>
-          <p:nvPr/>
-        </p:nvCxnSpPr>
-        <p:spPr>
-          <a:xfrm>
-            <a:off x="270933" y="0"/>
-            <a:ext cx="0" cy="5143500"/>
-          </a:xfrm>
-          <a:prstGeom prst="line">
-            <a:avLst/>
-          </a:prstGeom>
-        </p:spPr>
-        <p:style>
-          <a:lnRef idx="1">
-            <a:schemeClr val="accent1"/>
-          </a:lnRef>
-          <a:fillRef idx="0">
-            <a:schemeClr val="accent1"/>
-          </a:fillRef>
-          <a:effectRef idx="0">
-            <a:schemeClr val="accent1"/>
-          </a:effectRef>
-          <a:fontRef idx="minor">
-            <a:schemeClr val="tx1"/>
-          </a:fontRef>
-        </p:style>
-      </p:cxnSp>
     </p:spTree>
   </p:cSld>
   <p:clrMapOvr>
@@ -11584,78 +11008,6 @@
           </a:p>
         </p:txBody>
       </p:sp>
-      <p:cxnSp>
-        <p:nvCxnSpPr>
-          <p:cNvPr id="41" name="Straight Connector 40">
-            <a:extLst>
-              <a:ext uri="{FF2B5EF4-FFF2-40B4-BE49-F238E27FC236}">
-                <a16:creationId xmlns:a16="http://schemas.microsoft.com/office/drawing/2014/main" id="{F90E2BB6-1D29-3015-F78F-DC6F21B809C3}"/>
-              </a:ext>
-            </a:extLst>
-          </p:cNvPr>
-          <p:cNvCxnSpPr/>
-          <p:nvPr/>
-        </p:nvCxnSpPr>
-        <p:spPr>
-          <a:xfrm>
-            <a:off x="16935" y="729823"/>
-            <a:ext cx="9144000" cy="0"/>
-          </a:xfrm>
-          <a:prstGeom prst="line">
-            <a:avLst/>
-          </a:prstGeom>
-        </p:spPr>
-        <p:style>
-          <a:lnRef idx="1">
-            <a:schemeClr val="accent1"/>
-          </a:lnRef>
-          <a:fillRef idx="0">
-            <a:schemeClr val="accent1"/>
-          </a:fillRef>
-          <a:effectRef idx="0">
-            <a:schemeClr val="accent1"/>
-          </a:effectRef>
-          <a:fontRef idx="minor">
-            <a:schemeClr val="tx1"/>
-          </a:fontRef>
-        </p:style>
-      </p:cxnSp>
-      <p:cxnSp>
-        <p:nvCxnSpPr>
-          <p:cNvPr id="42" name="Straight Connector 41">
-            <a:extLst>
-              <a:ext uri="{FF2B5EF4-FFF2-40B4-BE49-F238E27FC236}">
-                <a16:creationId xmlns:a16="http://schemas.microsoft.com/office/drawing/2014/main" id="{2247CA63-3185-5FEA-7E25-0DBF5A6D3DC8}"/>
-              </a:ext>
-            </a:extLst>
-          </p:cNvPr>
-          <p:cNvCxnSpPr/>
-          <p:nvPr/>
-        </p:nvCxnSpPr>
-        <p:spPr>
-          <a:xfrm>
-            <a:off x="270933" y="0"/>
-            <a:ext cx="0" cy="5143500"/>
-          </a:xfrm>
-          <a:prstGeom prst="line">
-            <a:avLst/>
-          </a:prstGeom>
-        </p:spPr>
-        <p:style>
-          <a:lnRef idx="1">
-            <a:schemeClr val="accent1"/>
-          </a:lnRef>
-          <a:fillRef idx="0">
-            <a:schemeClr val="accent1"/>
-          </a:fillRef>
-          <a:effectRef idx="0">
-            <a:schemeClr val="accent1"/>
-          </a:effectRef>
-          <a:fontRef idx="minor">
-            <a:schemeClr val="tx1"/>
-          </a:fontRef>
-        </p:style>
-      </p:cxnSp>
     </p:spTree>
   </p:cSld>
   <p:clrMapOvr>
@@ -12902,78 +12254,6 @@
           </a:p>
         </p:txBody>
       </p:sp>
-      <p:cxnSp>
-        <p:nvCxnSpPr>
-          <p:cNvPr id="33" name="Straight Connector 32">
-            <a:extLst>
-              <a:ext uri="{FF2B5EF4-FFF2-40B4-BE49-F238E27FC236}">
-                <a16:creationId xmlns:a16="http://schemas.microsoft.com/office/drawing/2014/main" id="{F7E87784-256D-02E6-1DC3-CEC4F715F74F}"/>
-              </a:ext>
-            </a:extLst>
-          </p:cNvPr>
-          <p:cNvCxnSpPr/>
-          <p:nvPr/>
-        </p:nvCxnSpPr>
-        <p:spPr>
-          <a:xfrm>
-            <a:off x="16935" y="729823"/>
-            <a:ext cx="9144000" cy="0"/>
-          </a:xfrm>
-          <a:prstGeom prst="line">
-            <a:avLst/>
-          </a:prstGeom>
-        </p:spPr>
-        <p:style>
-          <a:lnRef idx="1">
-            <a:schemeClr val="accent1"/>
-          </a:lnRef>
-          <a:fillRef idx="0">
-            <a:schemeClr val="accent1"/>
-          </a:fillRef>
-          <a:effectRef idx="0">
-            <a:schemeClr val="accent1"/>
-          </a:effectRef>
-          <a:fontRef idx="minor">
-            <a:schemeClr val="tx1"/>
-          </a:fontRef>
-        </p:style>
-      </p:cxnSp>
-      <p:cxnSp>
-        <p:nvCxnSpPr>
-          <p:cNvPr id="34" name="Straight Connector 33">
-            <a:extLst>
-              <a:ext uri="{FF2B5EF4-FFF2-40B4-BE49-F238E27FC236}">
-                <a16:creationId xmlns:a16="http://schemas.microsoft.com/office/drawing/2014/main" id="{5B293F1D-4CF8-1EE6-A10B-85A7EC485E92}"/>
-              </a:ext>
-            </a:extLst>
-          </p:cNvPr>
-          <p:cNvCxnSpPr/>
-          <p:nvPr/>
-        </p:nvCxnSpPr>
-        <p:spPr>
-          <a:xfrm>
-            <a:off x="270933" y="0"/>
-            <a:ext cx="0" cy="5143500"/>
-          </a:xfrm>
-          <a:prstGeom prst="line">
-            <a:avLst/>
-          </a:prstGeom>
-        </p:spPr>
-        <p:style>
-          <a:lnRef idx="1">
-            <a:schemeClr val="accent1"/>
-          </a:lnRef>
-          <a:fillRef idx="0">
-            <a:schemeClr val="accent1"/>
-          </a:fillRef>
-          <a:effectRef idx="0">
-            <a:schemeClr val="accent1"/>
-          </a:effectRef>
-          <a:fontRef idx="minor">
-            <a:schemeClr val="tx1"/>
-          </a:fontRef>
-        </p:style>
-      </p:cxnSp>
     </p:spTree>
   </p:cSld>
   <p:clrMapOvr>
@@ -15599,78 +14879,6 @@
           </a:p>
         </p:txBody>
       </p:sp>
-      <p:cxnSp>
-        <p:nvCxnSpPr>
-          <p:cNvPr id="7" name="Straight Connector 6">
-            <a:extLst>
-              <a:ext uri="{FF2B5EF4-FFF2-40B4-BE49-F238E27FC236}">
-                <a16:creationId xmlns:a16="http://schemas.microsoft.com/office/drawing/2014/main" id="{45948E46-5A12-E6CB-96EB-1A32F9170182}"/>
-              </a:ext>
-            </a:extLst>
-          </p:cNvPr>
-          <p:cNvCxnSpPr/>
-          <p:nvPr/>
-        </p:nvCxnSpPr>
-        <p:spPr>
-          <a:xfrm>
-            <a:off x="16935" y="729823"/>
-            <a:ext cx="9144000" cy="0"/>
-          </a:xfrm>
-          <a:prstGeom prst="line">
-            <a:avLst/>
-          </a:prstGeom>
-        </p:spPr>
-        <p:style>
-          <a:lnRef idx="1">
-            <a:schemeClr val="accent1"/>
-          </a:lnRef>
-          <a:fillRef idx="0">
-            <a:schemeClr val="accent1"/>
-          </a:fillRef>
-          <a:effectRef idx="0">
-            <a:schemeClr val="accent1"/>
-          </a:effectRef>
-          <a:fontRef idx="minor">
-            <a:schemeClr val="tx1"/>
-          </a:fontRef>
-        </p:style>
-      </p:cxnSp>
-      <p:cxnSp>
-        <p:nvCxnSpPr>
-          <p:cNvPr id="8" name="Straight Connector 7">
-            <a:extLst>
-              <a:ext uri="{FF2B5EF4-FFF2-40B4-BE49-F238E27FC236}">
-                <a16:creationId xmlns:a16="http://schemas.microsoft.com/office/drawing/2014/main" id="{8FC92823-B449-6488-3F2A-883C7DCC4FF8}"/>
-              </a:ext>
-            </a:extLst>
-          </p:cNvPr>
-          <p:cNvCxnSpPr/>
-          <p:nvPr/>
-        </p:nvCxnSpPr>
-        <p:spPr>
-          <a:xfrm>
-            <a:off x="270933" y="0"/>
-            <a:ext cx="0" cy="5143500"/>
-          </a:xfrm>
-          <a:prstGeom prst="line">
-            <a:avLst/>
-          </a:prstGeom>
-        </p:spPr>
-        <p:style>
-          <a:lnRef idx="1">
-            <a:schemeClr val="accent1"/>
-          </a:lnRef>
-          <a:fillRef idx="0">
-            <a:schemeClr val="accent1"/>
-          </a:fillRef>
-          <a:effectRef idx="0">
-            <a:schemeClr val="accent1"/>
-          </a:effectRef>
-          <a:fontRef idx="minor">
-            <a:schemeClr val="tx1"/>
-          </a:fontRef>
-        </p:style>
-      </p:cxnSp>
     </p:spTree>
   </p:cSld>
   <p:clrMapOvr>

</xml_diff>